<commit_message>
Slide: espressioni spiegate una per una
</commit_message>
<xml_diff>
--- a/slide/slide-2-vpc.pptx
+++ b/slide/slide-2-vpc.pptx
@@ -8259,12 +8259,12 @@
         </p:nvSpPr>
         <p:spPr>
           <a:xfrm>
-            <a:off x="548640" y="2286000"/>
-            <a:ext cx="5669280" cy="868680"/>
+            <a:off x="548640" y="2240280"/>
+            <a:ext cx="5669280" cy="777240"/>
           </a:xfrm>
           <a:prstGeom prst="roundRect">
             <a:avLst>
-              <a:gd name="adj" fmla="val 8421"/>
+              <a:gd name="adj" fmla="val 9412"/>
             </a:avLst>
           </a:prstGeom>
           <a:solidFill>
@@ -8286,8 +8286,8 @@
         </p:nvSpPr>
         <p:spPr>
           <a:xfrm>
-            <a:off x="731520" y="2423160"/>
-            <a:ext cx="5303520" cy="594360"/>
+            <a:off x="731520" y="2377440"/>
+            <a:ext cx="5303520" cy="502920"/>
           </a:xfrm>
           <a:prstGeom prst="rect">
             <a:avLst/>
@@ -8325,7 +8325,7 @@
         </p:nvSpPr>
         <p:spPr>
           <a:xfrm>
-            <a:off x="6263640" y="2715768"/>
+            <a:off x="6263640" y="2624328"/>
             <a:ext cx="365760" cy="0"/>
           </a:xfrm>
           <a:prstGeom prst="line">
@@ -8349,12 +8349,12 @@
         </p:nvSpPr>
         <p:spPr>
           <a:xfrm>
-            <a:off x="6720840" y="2286000"/>
-            <a:ext cx="2651760" cy="868680"/>
+            <a:off x="6720840" y="2240280"/>
+            <a:ext cx="2651760" cy="777240"/>
           </a:xfrm>
           <a:prstGeom prst="roundRect">
             <a:avLst>
-              <a:gd name="adj" fmla="val 10526"/>
+              <a:gd name="adj" fmla="val 11765"/>
             </a:avLst>
           </a:prstGeom>
           <a:solidFill>
@@ -8376,8 +8376,8 @@
         </p:nvSpPr>
         <p:spPr>
           <a:xfrm>
-            <a:off x="6720840" y="2286000"/>
-            <a:ext cx="2651760" cy="868680"/>
+            <a:off x="6720840" y="2240280"/>
+            <a:ext cx="2651760" cy="777240"/>
           </a:xfrm>
           <a:prstGeom prst="rect">
             <a:avLst/>
@@ -8415,8 +8415,8 @@
         </p:nvSpPr>
         <p:spPr>
           <a:xfrm>
-            <a:off x="9509760" y="2286000"/>
-            <a:ext cx="2130552" cy="868680"/>
+            <a:off x="9509760" y="2240280"/>
+            <a:ext cx="2130552" cy="777240"/>
           </a:xfrm>
           <a:prstGeom prst="rect">
             <a:avLst/>
@@ -8432,7 +8432,7 @@
               <a:buNone/>
             </a:pPr>
             <a:r>
-              <a:rPr lang="en-US" sz="1500" b="1" dirty="0">
+              <a:rPr lang="en-US" sz="1600" b="1" dirty="0">
                 <a:solidFill>
                   <a:srgbClr val="22253A"/>
                 </a:solidFill>
@@ -8440,26 +8440,65 @@
                 <a:ea typeface="Calibri" pitchFamily="34" charset="-122"/>
                 <a:cs typeface="Calibri" pitchFamily="34" charset="-120"/>
               </a:rPr>
-              <a:t>[ ] → produce una LISTA</a:t>
-            </a:r>
-            <a:endParaRPr lang="en-US" sz="1500" dirty="0"/>
-          </a:p>
-        </p:txBody>
-      </p:sp>
-      <p:sp>
-        <p:nvSpPr>
-          <p:cNvPr id="13" name="Shape 10"/>
+              <a:t>[ ] → una LISTA</a:t>
+            </a:r>
+            <a:endParaRPr lang="en-US" sz="1600" dirty="0"/>
+          </a:p>
+        </p:txBody>
+      </p:sp>
+      <p:sp>
+        <p:nvSpPr>
+          <p:cNvPr id="13" name="Text 10"/>
+          <p:cNvSpPr txBox="1"/>
+          <p:nvPr/>
+        </p:nvSpPr>
+        <p:spPr>
+          <a:xfrm>
+            <a:off x="640080" y="3063240"/>
+            <a:ext cx="11094415" cy="384048"/>
+          </a:xfrm>
+          <a:prstGeom prst="rect">
+            <a:avLst/>
+          </a:prstGeom>
+          <a:noFill/>
+          <a:ln/>
+        </p:spPr>
+        <p:txBody>
+          <a:bodyPr wrap="square" lIns="0" tIns="0" rIns="0" bIns="0" rtlCol="0" anchor="ctr"/>
+          <a:lstStyle/>
+          <a:p>
+            <a:pPr algn="l" indent="0" marL="0">
+              <a:buNone/>
+            </a:pPr>
+            <a:r>
+              <a:rPr lang="en-US" sz="1600" i="1" dirty="0">
+                <a:solidFill>
+                  <a:srgbClr val="5F6478"/>
+                </a:solidFill>
+                <a:latin typeface="Calibri" pitchFamily="34" charset="0"/>
+                <a:ea typeface="Calibri" pitchFamily="34" charset="-122"/>
+                <a:cs typeface="Calibri" pitchFamily="34" charset="-120"/>
+              </a:rPr>
+              <a:t>Per ogni x fra "a" e "b", metti upper(x) in una lista.</a:t>
+            </a:r>
+            <a:endParaRPr lang="en-US" sz="1600" dirty="0"/>
+          </a:p>
+        </p:txBody>
+      </p:sp>
+      <p:sp>
+        <p:nvSpPr>
+          <p:cNvPr id="14" name="Shape 11"/>
           <p:cNvSpPr/>
           <p:nvPr/>
         </p:nvSpPr>
         <p:spPr>
           <a:xfrm>
             <a:off x="548640" y="3611880"/>
-            <a:ext cx="5669280" cy="868680"/>
+            <a:ext cx="5669280" cy="777240"/>
           </a:xfrm>
           <a:prstGeom prst="roundRect">
             <a:avLst>
-              <a:gd name="adj" fmla="val 8421"/>
+              <a:gd name="adj" fmla="val 9412"/>
             </a:avLst>
           </a:prstGeom>
           <a:solidFill>
@@ -8475,14 +8514,14 @@
       </p:sp>
       <p:sp>
         <p:nvSpPr>
-          <p:cNvPr id="14" name="Text 11"/>
+          <p:cNvPr id="15" name="Text 12"/>
           <p:cNvSpPr txBox="1"/>
           <p:nvPr/>
         </p:nvSpPr>
         <p:spPr>
           <a:xfrm>
             <a:off x="731520" y="3749040"/>
-            <a:ext cx="5303520" cy="594360"/>
+            <a:ext cx="5303520" cy="502920"/>
           </a:xfrm>
           <a:prstGeom prst="rect">
             <a:avLst/>
@@ -8514,13 +8553,13 @@
       </p:sp>
       <p:sp>
         <p:nvSpPr>
-          <p:cNvPr id="15" name="Shape 12"/>
+          <p:cNvPr id="16" name="Shape 13"/>
           <p:cNvSpPr/>
           <p:nvPr/>
         </p:nvSpPr>
         <p:spPr>
           <a:xfrm>
-            <a:off x="6263640" y="4041648"/>
+            <a:off x="6263640" y="3995928"/>
             <a:ext cx="365760" cy="0"/>
           </a:xfrm>
           <a:prstGeom prst="line">
@@ -8538,18 +8577,18 @@
       </p:sp>
       <p:sp>
         <p:nvSpPr>
-          <p:cNvPr id="16" name="Shape 13"/>
+          <p:cNvPr id="17" name="Shape 14"/>
           <p:cNvSpPr/>
           <p:nvPr/>
         </p:nvSpPr>
         <p:spPr>
           <a:xfrm>
             <a:off x="6720840" y="3611880"/>
-            <a:ext cx="2651760" cy="868680"/>
+            <a:ext cx="2651760" cy="777240"/>
           </a:xfrm>
           <a:prstGeom prst="roundRect">
             <a:avLst>
-              <a:gd name="adj" fmla="val 10526"/>
+              <a:gd name="adj" fmla="val 11765"/>
             </a:avLst>
           </a:prstGeom>
           <a:solidFill>
@@ -8565,14 +8604,14 @@
       </p:sp>
       <p:sp>
         <p:nvSpPr>
-          <p:cNvPr id="17" name="Text 14"/>
+          <p:cNvPr id="18" name="Text 15"/>
           <p:cNvSpPr txBox="1"/>
           <p:nvPr/>
         </p:nvSpPr>
         <p:spPr>
           <a:xfrm>
             <a:off x="6720840" y="3611880"/>
-            <a:ext cx="2651760" cy="868680"/>
+            <a:ext cx="2651760" cy="777240"/>
           </a:xfrm>
           <a:prstGeom prst="rect">
             <a:avLst/>
@@ -8604,14 +8643,14 @@
       </p:sp>
       <p:sp>
         <p:nvSpPr>
-          <p:cNvPr id="18" name="Text 15"/>
+          <p:cNvPr id="19" name="Text 16"/>
           <p:cNvSpPr txBox="1"/>
           <p:nvPr/>
         </p:nvSpPr>
         <p:spPr>
           <a:xfrm>
             <a:off x="9509760" y="3611880"/>
-            <a:ext cx="2130552" cy="868680"/>
+            <a:ext cx="2130552" cy="777240"/>
           </a:xfrm>
           <a:prstGeom prst="rect">
             <a:avLst/>
@@ -8627,7 +8666,7 @@
               <a:buNone/>
             </a:pPr>
             <a:r>
-              <a:rPr lang="en-US" sz="1500" b="1" dirty="0">
+              <a:rPr lang="en-US" sz="1600" b="1" dirty="0">
                 <a:solidFill>
                   <a:srgbClr val="22253A"/>
                 </a:solidFill>
@@ -8637,24 +8676,63 @@
               </a:rPr>
               <a:t>{ } e =&gt; → una MAPPA</a:t>
             </a:r>
-            <a:endParaRPr lang="en-US" sz="1500" dirty="0"/>
-          </a:p>
-        </p:txBody>
-      </p:sp>
-      <p:sp>
-        <p:nvSpPr>
-          <p:cNvPr id="19" name="Shape 16"/>
+            <a:endParaRPr lang="en-US" sz="1600" dirty="0"/>
+          </a:p>
+        </p:txBody>
+      </p:sp>
+      <p:sp>
+        <p:nvSpPr>
+          <p:cNvPr id="20" name="Text 17"/>
+          <p:cNvSpPr txBox="1"/>
+          <p:nvPr/>
+        </p:nvSpPr>
+        <p:spPr>
+          <a:xfrm>
+            <a:off x="640080" y="4434840"/>
+            <a:ext cx="11094415" cy="384048"/>
+          </a:xfrm>
+          <a:prstGeom prst="rect">
+            <a:avLst/>
+          </a:prstGeom>
+          <a:noFill/>
+          <a:ln/>
+        </p:spPr>
+        <p:txBody>
+          <a:bodyPr wrap="square" lIns="0" tIns="0" rIns="0" bIns="0" rtlCol="0" anchor="ctr"/>
+          <a:lstStyle/>
+          <a:p>
+            <a:pPr algn="l" indent="0" marL="0">
+              <a:buNone/>
+            </a:pPr>
+            <a:r>
+              <a:rPr lang="en-US" sz="1600" i="1" dirty="0">
+                <a:solidFill>
+                  <a:srgbClr val="5F6478"/>
+                </a:solidFill>
+                <a:latin typeface="Calibri" pitchFamily="34" charset="0"/>
+                <a:ea typeface="Calibri" pitchFamily="34" charset="-122"/>
+                <a:cs typeface="Calibri" pitchFamily="34" charset="-120"/>
+              </a:rPr>
+              <a:t>Per ogni x, crea la coppia chiave x → valore upper(x).</a:t>
+            </a:r>
+            <a:endParaRPr lang="en-US" sz="1600" dirty="0"/>
+          </a:p>
+        </p:txBody>
+      </p:sp>
+      <p:sp>
+        <p:nvSpPr>
+          <p:cNvPr id="21" name="Shape 18"/>
           <p:cNvSpPr/>
           <p:nvPr/>
         </p:nvSpPr>
         <p:spPr>
           <a:xfrm>
-            <a:off x="548640" y="4937760"/>
-            <a:ext cx="5669280" cy="868680"/>
+            <a:off x="548640" y="4983480"/>
+            <a:ext cx="5669280" cy="777240"/>
           </a:xfrm>
           <a:prstGeom prst="roundRect">
             <a:avLst>
-              <a:gd name="adj" fmla="val 8421"/>
+              <a:gd name="adj" fmla="val 9412"/>
             </a:avLst>
           </a:prstGeom>
           <a:solidFill>
@@ -8670,14 +8748,14 @@
       </p:sp>
       <p:sp>
         <p:nvSpPr>
-          <p:cNvPr id="20" name="Text 17"/>
+          <p:cNvPr id="22" name="Text 19"/>
           <p:cNvSpPr txBox="1"/>
           <p:nvPr/>
         </p:nvSpPr>
         <p:spPr>
           <a:xfrm>
-            <a:off x="731520" y="5074920"/>
-            <a:ext cx="5303520" cy="594360"/>
+            <a:off x="731520" y="5120640"/>
+            <a:ext cx="5303520" cy="502920"/>
           </a:xfrm>
           <a:prstGeom prst="rect">
             <a:avLst/>
@@ -8709,7 +8787,7 @@
       </p:sp>
       <p:sp>
         <p:nvSpPr>
-          <p:cNvPr id="21" name="Shape 18"/>
+          <p:cNvPr id="23" name="Shape 20"/>
           <p:cNvSpPr/>
           <p:nvPr/>
         </p:nvSpPr>
@@ -8733,18 +8811,18 @@
       </p:sp>
       <p:sp>
         <p:nvSpPr>
-          <p:cNvPr id="22" name="Shape 19"/>
+          <p:cNvPr id="24" name="Shape 21"/>
           <p:cNvSpPr/>
           <p:nvPr/>
         </p:nvSpPr>
         <p:spPr>
           <a:xfrm>
-            <a:off x="6720840" y="4937760"/>
-            <a:ext cx="2651760" cy="868680"/>
+            <a:off x="6720840" y="4983480"/>
+            <a:ext cx="2651760" cy="777240"/>
           </a:xfrm>
           <a:prstGeom prst="roundRect">
             <a:avLst>
-              <a:gd name="adj" fmla="val 10526"/>
+              <a:gd name="adj" fmla="val 11765"/>
             </a:avLst>
           </a:prstGeom>
           <a:solidFill>
@@ -8760,14 +8838,14 @@
       </p:sp>
       <p:sp>
         <p:nvSpPr>
-          <p:cNvPr id="23" name="Text 20"/>
+          <p:cNvPr id="25" name="Text 22"/>
           <p:cNvSpPr txBox="1"/>
           <p:nvPr/>
         </p:nvSpPr>
         <p:spPr>
           <a:xfrm>
-            <a:off x="6720840" y="4937760"/>
-            <a:ext cx="2651760" cy="868680"/>
+            <a:off x="6720840" y="4983480"/>
+            <a:ext cx="2651760" cy="777240"/>
           </a:xfrm>
           <a:prstGeom prst="rect">
             <a:avLst/>
@@ -8799,14 +8877,14 @@
       </p:sp>
       <p:sp>
         <p:nvSpPr>
-          <p:cNvPr id="24" name="Text 21"/>
+          <p:cNvPr id="26" name="Text 23"/>
           <p:cNvSpPr txBox="1"/>
           <p:nvPr/>
         </p:nvSpPr>
         <p:spPr>
           <a:xfrm>
-            <a:off x="9509760" y="4937760"/>
-            <a:ext cx="2130552" cy="868680"/>
+            <a:off x="9509760" y="4983480"/>
+            <a:ext cx="2130552" cy="777240"/>
           </a:xfrm>
           <a:prstGeom prst="rect">
             <a:avLst/>
@@ -8822,7 +8900,7 @@
               <a:buNone/>
             </a:pPr>
             <a:r>
-              <a:rPr lang="en-US" sz="1500" b="1" dirty="0">
+              <a:rPr lang="en-US" sz="1600" b="1" dirty="0">
                 <a:solidFill>
                   <a:srgbClr val="22253A"/>
                 </a:solidFill>
@@ -8830,9 +8908,48 @@
                 <a:ea typeface="Calibri" pitchFamily="34" charset="-122"/>
                 <a:cs typeface="Calibri" pitchFamily="34" charset="-120"/>
               </a:rPr>
-              <a:t>i = la posizione (da 0)</a:t>
-            </a:r>
-            <a:endParaRPr lang="en-US" sz="1500" dirty="0"/>
+              <a:t>i = la posizione</a:t>
+            </a:r>
+            <a:endParaRPr lang="en-US" sz="1600" dirty="0"/>
+          </a:p>
+        </p:txBody>
+      </p:sp>
+      <p:sp>
+        <p:nvSpPr>
+          <p:cNvPr id="27" name="Text 24"/>
+          <p:cNvSpPr txBox="1"/>
+          <p:nvPr/>
+        </p:nvSpPr>
+        <p:spPr>
+          <a:xfrm>
+            <a:off x="640080" y="5806440"/>
+            <a:ext cx="11094415" cy="384048"/>
+          </a:xfrm>
+          <a:prstGeom prst="rect">
+            <a:avLst/>
+          </a:prstGeom>
+          <a:noFill/>
+          <a:ln/>
+        </p:spPr>
+        <p:txBody>
+          <a:bodyPr wrap="square" lIns="0" tIns="0" rIns="0" bIns="0" rtlCol="0" anchor="ctr"/>
+          <a:lstStyle/>
+          <a:p>
+            <a:pPr algn="l" indent="0" marL="0">
+              <a:buNone/>
+            </a:pPr>
+            <a:r>
+              <a:rPr lang="en-US" sz="1600" i="1" dirty="0">
+                <a:solidFill>
+                  <a:srgbClr val="5F6478"/>
+                </a:solidFill>
+                <a:latin typeface="Calibri" pitchFamily="34" charset="0"/>
+                <a:ea typeface="Calibri" pitchFamily="34" charset="-122"/>
+                <a:cs typeface="Calibri" pitchFamily="34" charset="-120"/>
+              </a:rPr>
+              <a:t>Con due nomi: i è la posizione (si conta da 0), x l'elemento.</a:t>
+            </a:r>
+            <a:endParaRPr lang="en-US" sz="1600" dirty="0"/>
           </a:p>
         </p:txBody>
       </p:sp>

</xml_diff>